<commit_message>
Generate presentation for US Iran War
</commit_message>
<xml_diff>
--- a/docs/presentations/us-iran-war-2026-generated-deck.pptx
+++ b/docs/presentations/us-iran-war-2026-generated-deck.pptx
@@ -14,6 +14,10 @@
     <p:sldId id="262" r:id="rId13"/>
     <p:sldId id="263" r:id="rId14"/>
     <p:sldId id="264" r:id="rId15"/>
+    <p:sldId id="265" r:id="rId16"/>
+    <p:sldId id="266" r:id="rId17"/>
+    <p:sldId id="267" r:id="rId18"/>
+    <p:sldId id="268" r:id="rId19"/>
   </p:sldIdLst>
   <p:sldSz cx="12191695" cy="6858000" type="screen4x3"/>
   <p:notesSz cx="6858000" cy="9144000"/>
@@ -3246,7 +3250,955 @@
               </a:defRPr>
             </a:pPr>
             <a:r>
-              <a:t>TBD.</a:t>
+              <a:t>A U.S.–Iran war plus a U.S. blockade and Iran’s counter‑closure at Hormuz have created a structurally risky maritime regime; India must manage near‑term energy security and sanctions exposure while preparing for post‑war logistics re‑wiring.</a:t>
+            </a:r>
+          </a:p>
+        </p:txBody>
+      </p:sp>
+      <p:sp>
+        <p:nvSpPr>
+          <p:cNvPr id="6" name="TextBox 5"/>
+          <p:cNvSpPr txBox="1"/>
+          <p:nvPr/>
+        </p:nvSpPr>
+        <p:spPr>
+          <a:xfrm>
+            <a:off x="594360" y="6355080"/>
+            <a:ext cx="10698480" cy="201168"/>
+          </a:xfrm>
+          <a:prstGeom prst="rect">
+            <a:avLst/>
+          </a:prstGeom>
+          <a:noFill/>
+        </p:spPr>
+        <p:txBody>
+          <a:bodyPr wrap="none">
+            <a:spAutoFit/>
+          </a:bodyPr>
+          <a:lstStyle/>
+          <a:p>
+            <a:pPr algn="l"/>
+            <a:r>
+              <a:rPr sz="800">
+                <a:solidFill>
+                  <a:srgbClr val="67625A"/>
+                </a:solidFill>
+              </a:rPr>
+              <a:t>Project India | generated presentation draft | verify time-sensitive claims</a:t>
+            </a:r>
+          </a:p>
+        </p:txBody>
+      </p:sp>
+    </p:spTree>
+  </p:cSld>
+  <p:clrMapOvr>
+    <a:masterClrMapping/>
+  </p:clrMapOvr>
+</p:sld>
+</file>
+
+<file path=ppt/slides/slide10.xml><?xml version="1.0" encoding="utf-8"?>
+<p:sld xmlns:a="http://schemas.openxmlformats.org/drawingml/2006/main" xmlns:p="http://schemas.openxmlformats.org/presentationml/2006/main" xmlns:r="http://schemas.openxmlformats.org/officeDocument/2006/relationships">
+  <p:cSld>
+    <p:bg>
+      <p:bgPr>
+        <a:solidFill>
+          <a:srgbClr val="F7F1E7"/>
+        </a:solidFill>
+        <a:effectLst/>
+      </p:bgPr>
+    </p:bg>
+    <p:spTree>
+      <p:nvGrpSpPr>
+        <p:cNvPr id="1" name=""/>
+        <p:cNvGrpSpPr/>
+        <p:nvPr/>
+      </p:nvGrpSpPr>
+      <p:grpSpPr/>
+      <p:sp>
+        <p:nvSpPr>
+          <p:cNvPr id="2" name="Rectangle 1"/>
+          <p:cNvSpPr/>
+          <p:nvPr/>
+        </p:nvSpPr>
+        <p:spPr>
+          <a:xfrm>
+            <a:off x="594360" y="502920"/>
+            <a:ext cx="164592" cy="164592"/>
+          </a:xfrm>
+          <a:prstGeom prst="rect">
+            <a:avLst/>
+          </a:prstGeom>
+          <a:solidFill>
+            <a:srgbClr val="D97706"/>
+          </a:solidFill>
+          <a:ln>
+            <a:noFill/>
+          </a:ln>
+        </p:spPr>
+        <p:style>
+          <a:lnRef idx="1">
+            <a:schemeClr val="accent1"/>
+          </a:lnRef>
+          <a:fillRef idx="3">
+            <a:schemeClr val="accent1"/>
+          </a:fillRef>
+          <a:effectRef idx="2">
+            <a:schemeClr val="accent1"/>
+          </a:effectRef>
+          <a:fontRef idx="minor">
+            <a:schemeClr val="lt1"/>
+          </a:fontRef>
+        </p:style>
+        <p:txBody>
+          <a:bodyPr rtlCol="0" anchor="ctr"/>
+          <a:lstStyle/>
+          <a:p>
+            <a:pPr algn="ctr"/>
+          </a:p>
+        </p:txBody>
+      </p:sp>
+      <p:sp>
+        <p:nvSpPr>
+          <p:cNvPr id="3" name="TextBox 2"/>
+          <p:cNvSpPr txBox="1"/>
+          <p:nvPr/>
+        </p:nvSpPr>
+        <p:spPr>
+          <a:xfrm>
+            <a:off x="868680" y="438912"/>
+            <a:ext cx="2011680" cy="274320"/>
+          </a:xfrm>
+          <a:prstGeom prst="rect">
+            <a:avLst/>
+          </a:prstGeom>
+          <a:noFill/>
+        </p:spPr>
+        <p:txBody>
+          <a:bodyPr wrap="none">
+            <a:spAutoFit/>
+          </a:bodyPr>
+          <a:lstStyle/>
+          <a:p>
+            <a:r>
+              <a:rPr sz="900" b="1">
+                <a:solidFill>
+                  <a:srgbClr val="67625A"/>
+                </a:solidFill>
+              </a:rPr>
+              <a:t>SLIDE 9</a:t>
+            </a:r>
+          </a:p>
+        </p:txBody>
+      </p:sp>
+      <p:sp>
+        <p:nvSpPr>
+          <p:cNvPr id="4" name="TextBox 3"/>
+          <p:cNvSpPr txBox="1"/>
+          <p:nvPr/>
+        </p:nvSpPr>
+        <p:spPr>
+          <a:xfrm>
+            <a:off x="594360" y="932688"/>
+            <a:ext cx="10332720" cy="914400"/>
+          </a:xfrm>
+          <a:prstGeom prst="rect">
+            <a:avLst/>
+          </a:prstGeom>
+          <a:noFill/>
+        </p:spPr>
+        <p:txBody>
+          <a:bodyPr wrap="square">
+            <a:spAutoFit/>
+          </a:bodyPr>
+          <a:lstStyle/>
+          <a:p>
+            <a:r>
+              <a:rPr sz="2700" b="1">
+                <a:solidFill>
+                  <a:srgbClr val="151515"/>
+                </a:solidFill>
+              </a:rPr>
+              <a:t>Chabahar: strategic stake amid sanctions headwinds</a:t>
+            </a:r>
+          </a:p>
+        </p:txBody>
+      </p:sp>
+      <p:sp>
+        <p:nvSpPr>
+          <p:cNvPr id="5" name="TextBox 4"/>
+          <p:cNvSpPr txBox="1"/>
+          <p:nvPr/>
+        </p:nvSpPr>
+        <p:spPr>
+          <a:xfrm>
+            <a:off x="960120" y="2240280"/>
+            <a:ext cx="9784080" cy="3200400"/>
+          </a:xfrm>
+          <a:prstGeom prst="rect">
+            <a:avLst/>
+          </a:prstGeom>
+          <a:noFill/>
+        </p:spPr>
+        <p:txBody>
+          <a:bodyPr wrap="square">
+            <a:spAutoFit/>
+          </a:bodyPr>
+          <a:lstStyle/>
+          <a:p>
+            <a:pPr>
+              <a:spcAft>
+                <a:spcPts val="1000"/>
+              </a:spcAft>
+              <a:defRPr sz="1800">
+                <a:solidFill>
+                  <a:srgbClr val="151515"/>
+                </a:solidFill>
+              </a:defRPr>
+            </a:pPr>
+            <a:r>
+              <a:t>Proof object: PIB (contract); Lok Sabha Q&amp;A (waiver revocation/temporary cover)</a:t>
+            </a:r>
+          </a:p>
+          <a:p>
+            <a:pPr>
+              <a:spcAft>
+                <a:spcPts val="1000"/>
+              </a:spcAft>
+              <a:defRPr sz="1800">
+                <a:solidFill>
+                  <a:srgbClr val="151515"/>
+                </a:solidFill>
+              </a:defRPr>
+            </a:pPr>
+            <a:r>
+              <a:t>Evidence: 10‑year contract (May 13, 2024); U.S. revoked 2018 exception; temporary cover to Apr 26, 2026</a:t>
+            </a:r>
+          </a:p>
+          <a:p>
+            <a:pPr>
+              <a:spcAft>
+                <a:spcPts val="1000"/>
+              </a:spcAft>
+              <a:defRPr sz="1800">
+                <a:solidFill>
+                  <a:srgbClr val="151515"/>
+                </a:solidFill>
+              </a:defRPr>
+            </a:pPr>
+            <a:r>
+              <a:t>Source: ([pib.gov.in](https://pib.gov.in/PressReleasePage.aspx?PRID=2020454&amp;utm_source=openai))</a:t>
+            </a:r>
+          </a:p>
+        </p:txBody>
+      </p:sp>
+      <p:sp>
+        <p:nvSpPr>
+          <p:cNvPr id="6" name="TextBox 5"/>
+          <p:cNvSpPr txBox="1"/>
+          <p:nvPr/>
+        </p:nvSpPr>
+        <p:spPr>
+          <a:xfrm>
+            <a:off x="594360" y="6355080"/>
+            <a:ext cx="10698480" cy="201168"/>
+          </a:xfrm>
+          <a:prstGeom prst="rect">
+            <a:avLst/>
+          </a:prstGeom>
+          <a:noFill/>
+        </p:spPr>
+        <p:txBody>
+          <a:bodyPr wrap="none">
+            <a:spAutoFit/>
+          </a:bodyPr>
+          <a:lstStyle/>
+          <a:p>
+            <a:pPr algn="l"/>
+            <a:r>
+              <a:rPr sz="800">
+                <a:solidFill>
+                  <a:srgbClr val="67625A"/>
+                </a:solidFill>
+              </a:rPr>
+              <a:t>Project India | generated presentation draft | verify time-sensitive claims</a:t>
+            </a:r>
+          </a:p>
+        </p:txBody>
+      </p:sp>
+    </p:spTree>
+  </p:cSld>
+  <p:clrMapOvr>
+    <a:masterClrMapping/>
+  </p:clrMapOvr>
+</p:sld>
+</file>
+
+<file path=ppt/slides/slide11.xml><?xml version="1.0" encoding="utf-8"?>
+<p:sld xmlns:a="http://schemas.openxmlformats.org/drawingml/2006/main" xmlns:p="http://schemas.openxmlformats.org/presentationml/2006/main" xmlns:r="http://schemas.openxmlformats.org/officeDocument/2006/relationships">
+  <p:cSld>
+    <p:bg>
+      <p:bgPr>
+        <a:solidFill>
+          <a:srgbClr val="F7F1E7"/>
+        </a:solidFill>
+        <a:effectLst/>
+      </p:bgPr>
+    </p:bg>
+    <p:spTree>
+      <p:nvGrpSpPr>
+        <p:cNvPr id="1" name=""/>
+        <p:cNvGrpSpPr/>
+        <p:nvPr/>
+      </p:nvGrpSpPr>
+      <p:grpSpPr/>
+      <p:sp>
+        <p:nvSpPr>
+          <p:cNvPr id="2" name="Rectangle 1"/>
+          <p:cNvSpPr/>
+          <p:nvPr/>
+        </p:nvSpPr>
+        <p:spPr>
+          <a:xfrm>
+            <a:off x="594360" y="502920"/>
+            <a:ext cx="164592" cy="164592"/>
+          </a:xfrm>
+          <a:prstGeom prst="rect">
+            <a:avLst/>
+          </a:prstGeom>
+          <a:solidFill>
+            <a:srgbClr val="D97706"/>
+          </a:solidFill>
+          <a:ln>
+            <a:noFill/>
+          </a:ln>
+        </p:spPr>
+        <p:style>
+          <a:lnRef idx="1">
+            <a:schemeClr val="accent1"/>
+          </a:lnRef>
+          <a:fillRef idx="3">
+            <a:schemeClr val="accent1"/>
+          </a:fillRef>
+          <a:effectRef idx="2">
+            <a:schemeClr val="accent1"/>
+          </a:effectRef>
+          <a:fontRef idx="minor">
+            <a:schemeClr val="lt1"/>
+          </a:fontRef>
+        </p:style>
+        <p:txBody>
+          <a:bodyPr rtlCol="0" anchor="ctr"/>
+          <a:lstStyle/>
+          <a:p>
+            <a:pPr algn="ctr"/>
+          </a:p>
+        </p:txBody>
+      </p:sp>
+      <p:sp>
+        <p:nvSpPr>
+          <p:cNvPr id="3" name="TextBox 2"/>
+          <p:cNvSpPr txBox="1"/>
+          <p:nvPr/>
+        </p:nvSpPr>
+        <p:spPr>
+          <a:xfrm>
+            <a:off x="868680" y="438912"/>
+            <a:ext cx="2011680" cy="274320"/>
+          </a:xfrm>
+          <a:prstGeom prst="rect">
+            <a:avLst/>
+          </a:prstGeom>
+          <a:noFill/>
+        </p:spPr>
+        <p:txBody>
+          <a:bodyPr wrap="none">
+            <a:spAutoFit/>
+          </a:bodyPr>
+          <a:lstStyle/>
+          <a:p>
+            <a:r>
+              <a:rPr sz="900" b="1">
+                <a:solidFill>
+                  <a:srgbClr val="67625A"/>
+                </a:solidFill>
+              </a:rPr>
+              <a:t>SLIDE 10</a:t>
+            </a:r>
+          </a:p>
+        </p:txBody>
+      </p:sp>
+      <p:sp>
+        <p:nvSpPr>
+          <p:cNvPr id="4" name="TextBox 3"/>
+          <p:cNvSpPr txBox="1"/>
+          <p:nvPr/>
+        </p:nvSpPr>
+        <p:spPr>
+          <a:xfrm>
+            <a:off x="594360" y="932688"/>
+            <a:ext cx="10332720" cy="914400"/>
+          </a:xfrm>
+          <a:prstGeom prst="rect">
+            <a:avLst/>
+          </a:prstGeom>
+          <a:noFill/>
+        </p:spPr>
+        <p:txBody>
+          <a:bodyPr wrap="square">
+            <a:spAutoFit/>
+          </a:bodyPr>
+          <a:lstStyle/>
+          <a:p>
+            <a:r>
+              <a:rPr sz="2700" b="1">
+                <a:solidFill>
+                  <a:srgbClr val="151515"/>
+                </a:solidFill>
+              </a:rPr>
+              <a:t>Legal frame: blockade/closure under LOAC and UNCLOS principles</a:t>
+            </a:r>
+          </a:p>
+        </p:txBody>
+      </p:sp>
+      <p:sp>
+        <p:nvSpPr>
+          <p:cNvPr id="5" name="TextBox 4"/>
+          <p:cNvSpPr txBox="1"/>
+          <p:nvPr/>
+        </p:nvSpPr>
+        <p:spPr>
+          <a:xfrm>
+            <a:off x="960120" y="2240280"/>
+            <a:ext cx="9784080" cy="3200400"/>
+          </a:xfrm>
+          <a:prstGeom prst="rect">
+            <a:avLst/>
+          </a:prstGeom>
+          <a:noFill/>
+        </p:spPr>
+        <p:txBody>
+          <a:bodyPr wrap="square">
+            <a:spAutoFit/>
+          </a:bodyPr>
+          <a:lstStyle/>
+          <a:p>
+            <a:pPr>
+              <a:spcAft>
+                <a:spcPts val="1000"/>
+              </a:spcAft>
+              <a:defRPr sz="1800">
+                <a:solidFill>
+                  <a:srgbClr val="151515"/>
+                </a:solidFill>
+              </a:defRPr>
+            </a:pPr>
+            <a:r>
+              <a:t>Proof object: RUSI/Chatham analyses; San Remo background</a:t>
+            </a:r>
+          </a:p>
+          <a:p>
+            <a:pPr>
+              <a:spcAft>
+                <a:spcPts val="1000"/>
+              </a:spcAft>
+              <a:defRPr sz="1800">
+                <a:solidFill>
+                  <a:srgbClr val="151515"/>
+                </a:solidFill>
+              </a:defRPr>
+            </a:pPr>
+            <a:r>
+              <a:t>Evidence: Declaration/effectiveness/impartiality tests; Iran’s closure claims scrutinized</a:t>
+            </a:r>
+          </a:p>
+          <a:p>
+            <a:pPr>
+              <a:spcAft>
+                <a:spcPts val="1000"/>
+              </a:spcAft>
+              <a:defRPr sz="1800">
+                <a:solidFill>
+                  <a:srgbClr val="151515"/>
+                </a:solidFill>
+              </a:defRPr>
+            </a:pPr>
+            <a:r>
+              <a:t>Source: ([rusi.org](https://www.rusi.org/explore-our-research/publications/commentary/us-blockade-iran-how-it-might-function-or-not?utm_source=openai))</a:t>
+            </a:r>
+          </a:p>
+        </p:txBody>
+      </p:sp>
+      <p:sp>
+        <p:nvSpPr>
+          <p:cNvPr id="6" name="TextBox 5"/>
+          <p:cNvSpPr txBox="1"/>
+          <p:nvPr/>
+        </p:nvSpPr>
+        <p:spPr>
+          <a:xfrm>
+            <a:off x="594360" y="6355080"/>
+            <a:ext cx="10698480" cy="201168"/>
+          </a:xfrm>
+          <a:prstGeom prst="rect">
+            <a:avLst/>
+          </a:prstGeom>
+          <a:noFill/>
+        </p:spPr>
+        <p:txBody>
+          <a:bodyPr wrap="none">
+            <a:spAutoFit/>
+          </a:bodyPr>
+          <a:lstStyle/>
+          <a:p>
+            <a:pPr algn="l"/>
+            <a:r>
+              <a:rPr sz="800">
+                <a:solidFill>
+                  <a:srgbClr val="67625A"/>
+                </a:solidFill>
+              </a:rPr>
+              <a:t>Project India | generated presentation draft | verify time-sensitive claims</a:t>
+            </a:r>
+          </a:p>
+        </p:txBody>
+      </p:sp>
+    </p:spTree>
+  </p:cSld>
+  <p:clrMapOvr>
+    <a:masterClrMapping/>
+  </p:clrMapOvr>
+</p:sld>
+</file>
+
+<file path=ppt/slides/slide12.xml><?xml version="1.0" encoding="utf-8"?>
+<p:sld xmlns:a="http://schemas.openxmlformats.org/drawingml/2006/main" xmlns:p="http://schemas.openxmlformats.org/presentationml/2006/main" xmlns:r="http://schemas.openxmlformats.org/officeDocument/2006/relationships">
+  <p:cSld>
+    <p:bg>
+      <p:bgPr>
+        <a:solidFill>
+          <a:srgbClr val="F7F1E7"/>
+        </a:solidFill>
+        <a:effectLst/>
+      </p:bgPr>
+    </p:bg>
+    <p:spTree>
+      <p:nvGrpSpPr>
+        <p:cNvPr id="1" name=""/>
+        <p:cNvGrpSpPr/>
+        <p:nvPr/>
+      </p:nvGrpSpPr>
+      <p:grpSpPr/>
+      <p:sp>
+        <p:nvSpPr>
+          <p:cNvPr id="2" name="Rectangle 1"/>
+          <p:cNvSpPr/>
+          <p:nvPr/>
+        </p:nvSpPr>
+        <p:spPr>
+          <a:xfrm>
+            <a:off x="594360" y="502920"/>
+            <a:ext cx="164592" cy="164592"/>
+          </a:xfrm>
+          <a:prstGeom prst="rect">
+            <a:avLst/>
+          </a:prstGeom>
+          <a:solidFill>
+            <a:srgbClr val="D97706"/>
+          </a:solidFill>
+          <a:ln>
+            <a:noFill/>
+          </a:ln>
+        </p:spPr>
+        <p:style>
+          <a:lnRef idx="1">
+            <a:schemeClr val="accent1"/>
+          </a:lnRef>
+          <a:fillRef idx="3">
+            <a:schemeClr val="accent1"/>
+          </a:fillRef>
+          <a:effectRef idx="2">
+            <a:schemeClr val="accent1"/>
+          </a:effectRef>
+          <a:fontRef idx="minor">
+            <a:schemeClr val="lt1"/>
+          </a:fontRef>
+        </p:style>
+        <p:txBody>
+          <a:bodyPr rtlCol="0" anchor="ctr"/>
+          <a:lstStyle/>
+          <a:p>
+            <a:pPr algn="ctr"/>
+          </a:p>
+        </p:txBody>
+      </p:sp>
+      <p:sp>
+        <p:nvSpPr>
+          <p:cNvPr id="3" name="TextBox 2"/>
+          <p:cNvSpPr txBox="1"/>
+          <p:nvPr/>
+        </p:nvSpPr>
+        <p:spPr>
+          <a:xfrm>
+            <a:off x="868680" y="438912"/>
+            <a:ext cx="2011680" cy="274320"/>
+          </a:xfrm>
+          <a:prstGeom prst="rect">
+            <a:avLst/>
+          </a:prstGeom>
+          <a:noFill/>
+        </p:spPr>
+        <p:txBody>
+          <a:bodyPr wrap="none">
+            <a:spAutoFit/>
+          </a:bodyPr>
+          <a:lstStyle/>
+          <a:p>
+            <a:r>
+              <a:rPr sz="900" b="1">
+                <a:solidFill>
+                  <a:srgbClr val="67625A"/>
+                </a:solidFill>
+              </a:rPr>
+              <a:t>SLIDE 11</a:t>
+            </a:r>
+          </a:p>
+        </p:txBody>
+      </p:sp>
+      <p:sp>
+        <p:nvSpPr>
+          <p:cNvPr id="4" name="TextBox 3"/>
+          <p:cNvSpPr txBox="1"/>
+          <p:nvPr/>
+        </p:nvSpPr>
+        <p:spPr>
+          <a:xfrm>
+            <a:off x="594360" y="932688"/>
+            <a:ext cx="10332720" cy="914400"/>
+          </a:xfrm>
+          <a:prstGeom prst="rect">
+            <a:avLst/>
+          </a:prstGeom>
+          <a:noFill/>
+        </p:spPr>
+        <p:txBody>
+          <a:bodyPr wrap="square">
+            <a:spAutoFit/>
+          </a:bodyPr>
+          <a:lstStyle/>
+          <a:p>
+            <a:r>
+              <a:rPr sz="2700" b="1">
+                <a:solidFill>
+                  <a:srgbClr val="151515"/>
+                </a:solidFill>
+              </a:rPr>
+              <a:t>Macro impact: prices, insurance, logistics</a:t>
+            </a:r>
+          </a:p>
+        </p:txBody>
+      </p:sp>
+      <p:sp>
+        <p:nvSpPr>
+          <p:cNvPr id="5" name="TextBox 4"/>
+          <p:cNvSpPr txBox="1"/>
+          <p:nvPr/>
+        </p:nvSpPr>
+        <p:spPr>
+          <a:xfrm>
+            <a:off x="960120" y="2240280"/>
+            <a:ext cx="9784080" cy="3200400"/>
+          </a:xfrm>
+          <a:prstGeom prst="rect">
+            <a:avLst/>
+          </a:prstGeom>
+          <a:noFill/>
+        </p:spPr>
+        <p:txBody>
+          <a:bodyPr wrap="square">
+            <a:spAutoFit/>
+          </a:bodyPr>
+          <a:lstStyle/>
+          <a:p>
+            <a:pPr>
+              <a:spcAft>
+                <a:spcPts val="1000"/>
+              </a:spcAft>
+              <a:defRPr sz="1800">
+                <a:solidFill>
+                  <a:srgbClr val="151515"/>
+                </a:solidFill>
+              </a:defRPr>
+            </a:pPr>
+            <a:r>
+              <a:t>Proof object: IEA OMR; market/insurance commentary</a:t>
+            </a:r>
+          </a:p>
+          <a:p>
+            <a:pPr>
+              <a:spcAft>
+                <a:spcPts val="1000"/>
+              </a:spcAft>
+              <a:defRPr sz="1800">
+                <a:solidFill>
+                  <a:srgbClr val="151515"/>
+                </a:solidFill>
+              </a:defRPr>
+            </a:pPr>
+            <a:r>
+              <a:t>Evidence: Brent spikes; AIS-based partial openings; insurers’ risk aversion</a:t>
+            </a:r>
+          </a:p>
+          <a:p>
+            <a:pPr>
+              <a:spcAft>
+                <a:spcPts val="1000"/>
+              </a:spcAft>
+              <a:defRPr sz="1800">
+                <a:solidFill>
+                  <a:srgbClr val="151515"/>
+                </a:solidFill>
+              </a:defRPr>
+            </a:pPr>
+            <a:r>
+              <a:t>Source: ([iea.org](https://www.iea.org/reports/oil-market-report-march-2026?ftag=MSFd61514f&amp;utm_source=openai))</a:t>
+            </a:r>
+          </a:p>
+        </p:txBody>
+      </p:sp>
+      <p:sp>
+        <p:nvSpPr>
+          <p:cNvPr id="6" name="TextBox 5"/>
+          <p:cNvSpPr txBox="1"/>
+          <p:nvPr/>
+        </p:nvSpPr>
+        <p:spPr>
+          <a:xfrm>
+            <a:off x="594360" y="6355080"/>
+            <a:ext cx="10698480" cy="201168"/>
+          </a:xfrm>
+          <a:prstGeom prst="rect">
+            <a:avLst/>
+          </a:prstGeom>
+          <a:noFill/>
+        </p:spPr>
+        <p:txBody>
+          <a:bodyPr wrap="none">
+            <a:spAutoFit/>
+          </a:bodyPr>
+          <a:lstStyle/>
+          <a:p>
+            <a:pPr algn="l"/>
+            <a:r>
+              <a:rPr sz="800">
+                <a:solidFill>
+                  <a:srgbClr val="67625A"/>
+                </a:solidFill>
+              </a:rPr>
+              <a:t>Project India | generated presentation draft | verify time-sensitive claims</a:t>
+            </a:r>
+          </a:p>
+        </p:txBody>
+      </p:sp>
+    </p:spTree>
+  </p:cSld>
+  <p:clrMapOvr>
+    <a:masterClrMapping/>
+  </p:clrMapOvr>
+</p:sld>
+</file>
+
+<file path=ppt/slides/slide13.xml><?xml version="1.0" encoding="utf-8"?>
+<p:sld xmlns:a="http://schemas.openxmlformats.org/drawingml/2006/main" xmlns:p="http://schemas.openxmlformats.org/presentationml/2006/main" xmlns:r="http://schemas.openxmlformats.org/officeDocument/2006/relationships">
+  <p:cSld>
+    <p:bg>
+      <p:bgPr>
+        <a:solidFill>
+          <a:srgbClr val="F7F1E7"/>
+        </a:solidFill>
+        <a:effectLst/>
+      </p:bgPr>
+    </p:bg>
+    <p:spTree>
+      <p:nvGrpSpPr>
+        <p:cNvPr id="1" name=""/>
+        <p:cNvGrpSpPr/>
+        <p:nvPr/>
+      </p:nvGrpSpPr>
+      <p:grpSpPr/>
+      <p:sp>
+        <p:nvSpPr>
+          <p:cNvPr id="2" name="Rectangle 1"/>
+          <p:cNvSpPr/>
+          <p:nvPr/>
+        </p:nvSpPr>
+        <p:spPr>
+          <a:xfrm>
+            <a:off x="594360" y="502920"/>
+            <a:ext cx="164592" cy="164592"/>
+          </a:xfrm>
+          <a:prstGeom prst="rect">
+            <a:avLst/>
+          </a:prstGeom>
+          <a:solidFill>
+            <a:srgbClr val="D97706"/>
+          </a:solidFill>
+          <a:ln>
+            <a:noFill/>
+          </a:ln>
+        </p:spPr>
+        <p:style>
+          <a:lnRef idx="1">
+            <a:schemeClr val="accent1"/>
+          </a:lnRef>
+          <a:fillRef idx="3">
+            <a:schemeClr val="accent1"/>
+          </a:fillRef>
+          <a:effectRef idx="2">
+            <a:schemeClr val="accent1"/>
+          </a:effectRef>
+          <a:fontRef idx="minor">
+            <a:schemeClr val="lt1"/>
+          </a:fontRef>
+        </p:style>
+        <p:txBody>
+          <a:bodyPr rtlCol="0" anchor="ctr"/>
+          <a:lstStyle/>
+          <a:p>
+            <a:pPr algn="ctr"/>
+          </a:p>
+        </p:txBody>
+      </p:sp>
+      <p:sp>
+        <p:nvSpPr>
+          <p:cNvPr id="3" name="TextBox 2"/>
+          <p:cNvSpPr txBox="1"/>
+          <p:nvPr/>
+        </p:nvSpPr>
+        <p:spPr>
+          <a:xfrm>
+            <a:off x="868680" y="438912"/>
+            <a:ext cx="2011680" cy="274320"/>
+          </a:xfrm>
+          <a:prstGeom prst="rect">
+            <a:avLst/>
+          </a:prstGeom>
+          <a:noFill/>
+        </p:spPr>
+        <p:txBody>
+          <a:bodyPr wrap="none">
+            <a:spAutoFit/>
+          </a:bodyPr>
+          <a:lstStyle/>
+          <a:p>
+            <a:r>
+              <a:rPr sz="900" b="1">
+                <a:solidFill>
+                  <a:srgbClr val="67625A"/>
+                </a:solidFill>
+              </a:rPr>
+              <a:t>SLIDE 12</a:t>
+            </a:r>
+          </a:p>
+        </p:txBody>
+      </p:sp>
+      <p:sp>
+        <p:nvSpPr>
+          <p:cNvPr id="4" name="TextBox 3"/>
+          <p:cNvSpPr txBox="1"/>
+          <p:nvPr/>
+        </p:nvSpPr>
+        <p:spPr>
+          <a:xfrm>
+            <a:off x="594360" y="932688"/>
+            <a:ext cx="10332720" cy="914400"/>
+          </a:xfrm>
+          <a:prstGeom prst="rect">
+            <a:avLst/>
+          </a:prstGeom>
+          <a:noFill/>
+        </p:spPr>
+        <p:txBody>
+          <a:bodyPr wrap="square">
+            <a:spAutoFit/>
+          </a:bodyPr>
+          <a:lstStyle/>
+          <a:p>
+            <a:r>
+              <a:rPr sz="2700" b="1">
+                <a:solidFill>
+                  <a:srgbClr val="151515"/>
+                </a:solidFill>
+              </a:rPr>
+              <a:t>India’s immediate posture: escorts + price management</a:t>
+            </a:r>
+          </a:p>
+        </p:txBody>
+      </p:sp>
+      <p:sp>
+        <p:nvSpPr>
+          <p:cNvPr id="5" name="TextBox 4"/>
+          <p:cNvSpPr txBox="1"/>
+          <p:nvPr/>
+        </p:nvSpPr>
+        <p:spPr>
+          <a:xfrm>
+            <a:off x="960120" y="2240280"/>
+            <a:ext cx="9784080" cy="3200400"/>
+          </a:xfrm>
+          <a:prstGeom prst="rect">
+            <a:avLst/>
+          </a:prstGeom>
+          <a:noFill/>
+        </p:spPr>
+        <p:txBody>
+          <a:bodyPr wrap="square">
+            <a:spAutoFit/>
+          </a:bodyPr>
+          <a:lstStyle/>
+          <a:p>
+            <a:pPr>
+              <a:spcAft>
+                <a:spcPts val="1000"/>
+              </a:spcAft>
+              <a:defRPr sz="1800">
+                <a:solidFill>
+                  <a:srgbClr val="151515"/>
+                </a:solidFill>
+              </a:defRPr>
+            </a:pPr>
+            <a:r>
+              <a:t>Proof object: DGS/MEA notices; policy measures</a:t>
+            </a:r>
+          </a:p>
+          <a:p>
+            <a:pPr>
+              <a:spcAft>
+                <a:spcPts val="1000"/>
+              </a:spcAft>
+              <a:defRPr sz="1800">
+                <a:solidFill>
+                  <a:srgbClr val="151515"/>
+                </a:solidFill>
+              </a:defRPr>
+            </a:pPr>
+            <a:r>
+              <a:t>Evidence: Routing/crew advisories; excise adjustments; price holds</a:t>
+            </a:r>
+          </a:p>
+          <a:p>
+            <a:pPr>
+              <a:spcAft>
+                <a:spcPts val="1000"/>
+              </a:spcAft>
+              <a:defRPr sz="1800">
+                <a:solidFill>
+                  <a:srgbClr val="151515"/>
+                </a:solidFill>
+              </a:defRPr>
+            </a:pPr>
+            <a:r>
+              <a:t>Source: ([dgshipping.gov.in](https://www.dgshipping.gov.in/WriteReadData/News/202602280342249592926MARSECDGSCircular08of2026dated28Feb20262.pdf?utm_source=openai))</a:t>
             </a:r>
           </a:p>
         </p:txBody>
@@ -3382,7 +4334,7 @@
                   <a:srgbClr val="67625A"/>
                 </a:solidFill>
               </a:rPr>
-              <a:t>WHY IT MATTERS</a:t>
+              <a:t>SLIDE 1</a:t>
             </a:r>
           </a:p>
         </p:txBody>
@@ -3415,7 +4367,7 @@
                   <a:srgbClr val="151515"/>
                 </a:solidFill>
               </a:rPr>
-              <a:t>This topic matters because it changes the strategic picture.</a:t>
+              <a:t>Claim title</a:t>
             </a:r>
           </a:p>
         </p:txBody>
@@ -3453,7 +4405,37 @@
               </a:defRPr>
             </a:pPr>
             <a:r>
-              <a:t>TBD.</a:t>
+              <a:t>Proof object:</a:t>
+            </a:r>
+          </a:p>
+          <a:p>
+            <a:pPr>
+              <a:spcAft>
+                <a:spcPts val="1000"/>
+              </a:spcAft>
+              <a:defRPr sz="1800">
+                <a:solidFill>
+                  <a:srgbClr val="151515"/>
+                </a:solidFill>
+              </a:defRPr>
+            </a:pPr>
+            <a:r>
+              <a:t>Evidence:</a:t>
+            </a:r>
+          </a:p>
+          <a:p>
+            <a:pPr>
+              <a:spcAft>
+                <a:spcPts val="1000"/>
+              </a:spcAft>
+              <a:defRPr sz="1800">
+                <a:solidFill>
+                  <a:srgbClr val="151515"/>
+                </a:solidFill>
+              </a:defRPr>
+            </a:pPr>
+            <a:r>
+              <a:t>Source:</a:t>
             </a:r>
           </a:p>
         </p:txBody>
@@ -3589,7 +4571,7 @@
                   <a:srgbClr val="67625A"/>
                 </a:solidFill>
               </a:rPr>
-              <a:t>CURRENT STATE</a:t>
+              <a:t>SLIDE 2</a:t>
             </a:r>
           </a:p>
         </p:txBody>
@@ -3622,7 +4604,7 @@
                   <a:srgbClr val="151515"/>
                 </a:solidFill>
               </a:rPr>
-              <a:t>The current state gives us the baseline for analysis.</a:t>
+              <a:t>War began Feb 28, 2026; Iran’s Supreme Leader killed</a:t>
             </a:r>
           </a:p>
         </p:txBody>
@@ -3660,7 +4642,37 @@
               </a:defRPr>
             </a:pPr>
             <a:r>
-              <a:t>TBD.</a:t>
+              <a:t>Proof object: Opening-day reporting and official statements</a:t>
+            </a:r>
+          </a:p>
+          <a:p>
+            <a:pPr>
+              <a:spcAft>
+                <a:spcPts val="1000"/>
+              </a:spcAft>
+              <a:defRPr sz="1800">
+                <a:solidFill>
+                  <a:srgbClr val="151515"/>
+                </a:solidFill>
+              </a:defRPr>
+            </a:pPr>
+            <a:r>
+              <a:t>Evidence: Coordinated U.S.–Israeli strikes; AP/Reuters confirm Khamenei killed</a:t>
+            </a:r>
+          </a:p>
+          <a:p>
+            <a:pPr>
+              <a:spcAft>
+                <a:spcPts val="1000"/>
+              </a:spcAft>
+              <a:defRPr sz="1800">
+                <a:solidFill>
+                  <a:srgbClr val="151515"/>
+                </a:solidFill>
+              </a:defRPr>
+            </a:pPr>
+            <a:r>
+              <a:t>Source: ([apnews.com](https://apnews.com/article/8de8054f3abd4688f894c657467ee3dd?utm_source=openai))</a:t>
             </a:r>
           </a:p>
         </p:txBody>
@@ -3796,7 +4808,7 @@
                   <a:srgbClr val="67625A"/>
                 </a:solidFill>
               </a:rPr>
-              <a:t>CONTEXT</a:t>
+              <a:t>SLIDE 3</a:t>
             </a:r>
           </a:p>
         </p:txBody>
@@ -3829,7 +4841,7 @@
                   <a:srgbClr val="151515"/>
                 </a:solidFill>
               </a:rPr>
-              <a:t>Historical context prevents shallow conclusions.</a:t>
+              <a:t>U.S. naval blockade declared Apr 12; enforcement ongoing</a:t>
             </a:r>
           </a:p>
         </p:txBody>
@@ -3867,7 +4879,37 @@
               </a:defRPr>
             </a:pPr>
             <a:r>
-              <a:t>TBD.</a:t>
+              <a:t>Proof object: CENTCOM press release</a:t>
+            </a:r>
+          </a:p>
+          <a:p>
+            <a:pPr>
+              <a:spcAft>
+                <a:spcPts val="1000"/>
+              </a:spcAft>
+              <a:defRPr sz="1800">
+                <a:solidFill>
+                  <a:srgbClr val="151515"/>
+                </a:solidFill>
+              </a:defRPr>
+            </a:pPr>
+            <a:r>
+              <a:t>Evidence: Impartial blockade of ships entering/exiting Iranian ports; effective Apr 13</a:t>
+            </a:r>
+          </a:p>
+          <a:p>
+            <a:pPr>
+              <a:spcAft>
+                <a:spcPts val="1000"/>
+              </a:spcAft>
+              <a:defRPr sz="1800">
+                <a:solidFill>
+                  <a:srgbClr val="151515"/>
+                </a:solidFill>
+              </a:defRPr>
+            </a:pPr>
+            <a:r>
+              <a:t>Source: ([centcom.mil](https://www.centcom.mil/MEDIA/PRESS-RELEASES/Press-Release-View/Article/4457255/us-to-blockade-ships-entering-or-exiting-iranian-ports/))</a:t>
             </a:r>
           </a:p>
         </p:txBody>
@@ -4003,7 +5045,7 @@
                   <a:srgbClr val="67625A"/>
                 </a:solidFill>
               </a:rPr>
-              <a:t>ACTORS</a:t>
+              <a:t>SLIDE 4</a:t>
             </a:r>
           </a:p>
         </p:txBody>
@@ -4036,7 +5078,7 @@
                   <a:srgbClr val="151515"/>
                 </a:solidFill>
               </a:rPr>
-              <a:t>The key actors define incentives and constraints.</a:t>
+              <a:t>Project Freedom escorts coexist with blockade and intermittent fire</a:t>
             </a:r>
           </a:p>
         </p:txBody>
@@ -4074,7 +5116,37 @@
               </a:defRPr>
             </a:pPr>
             <a:r>
-              <a:t>TBD</a:t>
+              <a:t>Proof object: CENTCOM/press notices</a:t>
+            </a:r>
+          </a:p>
+          <a:p>
+            <a:pPr>
+              <a:spcAft>
+                <a:spcPts val="1000"/>
+              </a:spcAft>
+              <a:defRPr sz="1800">
+                <a:solidFill>
+                  <a:srgbClr val="151515"/>
+                </a:solidFill>
+              </a:defRPr>
+            </a:pPr>
+            <a:r>
+              <a:t>Evidence: U.S. began “guiding” ships through Hormuz; skirmishes and mine-clearance reported</a:t>
+            </a:r>
+          </a:p>
+          <a:p>
+            <a:pPr>
+              <a:spcAft>
+                <a:spcPts val="1000"/>
+              </a:spcAft>
+              <a:defRPr sz="1800">
+                <a:solidFill>
+                  <a:srgbClr val="151515"/>
+                </a:solidFill>
+              </a:defRPr>
+            </a:pPr>
+            <a:r>
+              <a:t>Source: ([centcom.mil](https://www.centcom.mil/MEDIA/PRESS-RELEASES/Press-Release-View/Article/4476318/us-military-supports-launch-of-project-freedom-in-strait-of-hormuz/))</a:t>
             </a:r>
           </a:p>
         </p:txBody>
@@ -4210,7 +5282,7 @@
                   <a:srgbClr val="67625A"/>
                 </a:solidFill>
               </a:rPr>
-              <a:t>DATA</a:t>
+              <a:t>SLIDE 5</a:t>
             </a:r>
           </a:p>
         </p:txBody>
@@ -4243,7 +5315,7 @@
                   <a:srgbClr val="151515"/>
                 </a:solidFill>
               </a:rPr>
-              <a:t>The next analytical layer is data and indicators.</a:t>
+              <a:t>Ceasefire diplomacy: talks held; UNSC split</a:t>
             </a:r>
           </a:p>
         </p:txBody>
@@ -4281,7 +5353,37 @@
               </a:defRPr>
             </a:pPr>
             <a:r>
-              <a:t>TBD</a:t>
+              <a:t>Proof object: HoC Library brief; UNSC records</a:t>
+            </a:r>
+          </a:p>
+          <a:p>
+            <a:pPr>
+              <a:spcAft>
+                <a:spcPts val="1000"/>
+              </a:spcAft>
+              <a:defRPr sz="1800">
+                <a:solidFill>
+                  <a:srgbClr val="151515"/>
+                </a:solidFill>
+              </a:defRPr>
+            </a:pPr>
+            <a:r>
+              <a:t>Evidence: Conditional ceasefire (from Apr 8) with Islamabad talks; Res. 2817 adopted; later Hormuz draft vetoed</a:t>
+            </a:r>
+          </a:p>
+          <a:p>
+            <a:pPr>
+              <a:spcAft>
+                <a:spcPts val="1000"/>
+              </a:spcAft>
+              <a:defRPr sz="1800">
+                <a:solidFill>
+                  <a:srgbClr val="151515"/>
+                </a:solidFill>
+              </a:defRPr>
+            </a:pPr>
+            <a:r>
+              <a:t>Source: ([commonslibrary.parliament.uk](https://commonslibrary.parliament.uk/research-briefings/cbp-10637/))</a:t>
             </a:r>
           </a:p>
         </p:txBody>
@@ -4417,7 +5519,7 @@
                   <a:srgbClr val="67625A"/>
                 </a:solidFill>
               </a:rPr>
-              <a:t>OPPORTUNITIES</a:t>
+              <a:t>SLIDE 6</a:t>
             </a:r>
           </a:p>
         </p:txBody>
@@ -4450,7 +5552,7 @@
                   <a:srgbClr val="151515"/>
                 </a:solidFill>
               </a:rPr>
-              <a:t>The opportunity set is where strategy becomes concrete.</a:t>
+              <a:t>IAEA: no initial nuclear-site damage; verification essential</a:t>
             </a:r>
           </a:p>
         </p:txBody>
@@ -4488,7 +5590,37 @@
               </a:defRPr>
             </a:pPr>
             <a:r>
-              <a:t>TBD</a:t>
+              <a:t>Proof object: IAEA DG statement</a:t>
+            </a:r>
+          </a:p>
+          <a:p>
+            <a:pPr>
+              <a:spcAft>
+                <a:spcPts val="1000"/>
+              </a:spcAft>
+              <a:defRPr sz="1800">
+                <a:solidFill>
+                  <a:srgbClr val="151515"/>
+                </a:solidFill>
+              </a:defRPr>
+            </a:pPr>
+            <a:r>
+              <a:t>Evidence: “No indication” of damage (Mar 2); calls for robust checks in any deal</a:t>
+            </a:r>
+          </a:p>
+          <a:p>
+            <a:pPr>
+              <a:spcAft>
+                <a:spcPts val="1000"/>
+              </a:spcAft>
+              <a:defRPr sz="1800">
+                <a:solidFill>
+                  <a:srgbClr val="151515"/>
+                </a:solidFill>
+              </a:defRPr>
+            </a:pPr>
+            <a:r>
+              <a:t>Source: ([investing.com](https://www.investing.com/news/world-news/no-sign-irans-nuclear-sites-were-hit-iaea-says-but-iran-alleges-one-was-4533937?utm_source=openai))</a:t>
             </a:r>
           </a:p>
         </p:txBody>
@@ -4624,7 +5756,7 @@
                   <a:srgbClr val="67625A"/>
                 </a:solidFill>
               </a:rPr>
-              <a:t>RISKS</a:t>
+              <a:t>SLIDE 7</a:t>
             </a:r>
           </a:p>
         </p:txBody>
@@ -4657,7 +5789,7 @@
                   <a:srgbClr val="151515"/>
                 </a:solidFill>
               </a:rPr>
-              <a:t>The risks show where the story can break.</a:t>
+              <a:t>Hormuz disruption is historic in scale</a:t>
             </a:r>
           </a:p>
         </p:txBody>
@@ -4695,7 +5827,37 @@
               </a:defRPr>
             </a:pPr>
             <a:r>
-              <a:t>TBD</a:t>
+              <a:t>Proof object: IEA OMR/analysis</a:t>
+            </a:r>
+          </a:p>
+          <a:p>
+            <a:pPr>
+              <a:spcAft>
+                <a:spcPts val="1000"/>
+              </a:spcAft>
+              <a:defRPr sz="1800">
+                <a:solidFill>
+                  <a:srgbClr val="151515"/>
+                </a:solidFill>
+              </a:defRPr>
+            </a:pPr>
+            <a:r>
+              <a:t>Evidence: “Largest supply disruption in the history of the global oil market”</a:t>
+            </a:r>
+          </a:p>
+          <a:p>
+            <a:pPr>
+              <a:spcAft>
+                <a:spcPts val="1000"/>
+              </a:spcAft>
+              <a:defRPr sz="1800">
+                <a:solidFill>
+                  <a:srgbClr val="151515"/>
+                </a:solidFill>
+              </a:defRPr>
+            </a:pPr>
+            <a:r>
+              <a:t>Source: ([iea.org](https://www.iea.org/reports/sheltering-from-oil-shocks/introduction-and-context?utm_source=openai))</a:t>
             </a:r>
           </a:p>
         </p:txBody>
@@ -4831,7 +5993,7 @@
                   <a:srgbClr val="67625A"/>
                 </a:solidFill>
               </a:rPr>
-              <a:t>WATCH NEXT</a:t>
+              <a:t>SLIDE 8</a:t>
             </a:r>
           </a:p>
         </p:txBody>
@@ -4864,7 +6026,7 @@
                   <a:srgbClr val="151515"/>
                 </a:solidFill>
               </a:rPr>
-              <a:t>The follow-up agenda should drive the next research cycle.</a:t>
+              <a:t>India’s exposure: dependency, SPR, stranded ships</a:t>
             </a:r>
           </a:p>
         </p:txBody>
@@ -4902,7 +6064,37 @@
               </a:defRPr>
             </a:pPr>
             <a:r>
-              <a:t>TBD</a:t>
+              <a:t>Proof object: PPAC/ISPRL/NDTV</a:t>
+            </a:r>
+          </a:p>
+          <a:p>
+            <a:pPr>
+              <a:spcAft>
+                <a:spcPts val="1000"/>
+              </a:spcAft>
+              <a:defRPr sz="1800">
+                <a:solidFill>
+                  <a:srgbClr val="151515"/>
+                </a:solidFill>
+              </a:defRPr>
+            </a:pPr>
+            <a:r>
+              <a:t>Evidence: ~88–89% import dependence; SPR 5.33 MMT (~64% filled); 22 India‑bound ships and 611 seafarers stranded mid‑March; Navy escorts</a:t>
+            </a:r>
+          </a:p>
+          <a:p>
+            <a:pPr>
+              <a:spcAft>
+                <a:spcPts val="1000"/>
+              </a:spcAft>
+              <a:defRPr sz="1800">
+                <a:solidFill>
+                  <a:srgbClr val="151515"/>
+                </a:solidFill>
+              </a:defRPr>
+            </a:pPr>
+            <a:r>
+              <a:t>Source: ([indianexpress.com](https://indianexpress.com/article/explained/explained-economics/indias-reliance-on-imported-oil-may-hit-fresh-high-in-fy26-10548802/?utm_source=openai))</a:t>
             </a:r>
           </a:p>
         </p:txBody>

</xml_diff>